<commit_message>
docs(examples): fix gantt date axis overlap in mermaid diagram example
The gantt slide rendered every day as an axis tick labelled with the full
YYYY-MM-DD date, so ~18 labels overlapped into an unreadable smear. Switch
to weekly ticks with a short axisFormat (weekday monday, tickInterval 1week,
axisFormat %b %d) so the axis reads Jan 01 / Jan 08 / Jan 15. Applied to
both the .sh and .py twin; the shipped diagram.pptx is regenerated.
</commit_message>
<xml_diff>
--- a/examples/ppt/diagram.pptx
+++ b/examples/ppt/diagram.pptx
@@ -5,29 +5,29 @@
     <p:sldMasterId xmlns:r="http://schemas.openxmlformats.org/officeDocument/2006/relationships" id="2147483648" r:id="rId1"/>
   </p:sldMasterIdLst>
   <p:sldIdLst>
-    <p:sldId id="256" r:id="Re3d1d2176c6449cd"/>
-    <p:sldId id="257" r:id="Re8c399aa1a664113"/>
-    <p:sldId id="258" r:id="R4d82f7e39e474f70"/>
-    <p:sldId id="259" r:id="Reda539e5b354460a"/>
-    <p:sldId id="260" r:id="Rd8a8c38649344925"/>
-    <p:sldId id="261" r:id="R339b06c5941846d4"/>
-    <p:sldId id="262" r:id="R89603cb20064442c"/>
-    <p:sldId id="263" r:id="R440c14f6f4974dc0"/>
-    <p:sldId id="264" r:id="R48e4af8a1e0b4dc5"/>
-    <p:sldId id="265" r:id="R22bca29bd7fc49d8"/>
-    <p:sldId id="266" r:id="Raead6209709340e1"/>
-    <p:sldId id="267" r:id="R77aa1d0453c240cb"/>
-    <p:sldId id="268" r:id="R79395240c02f4bbf"/>
-    <p:sldId id="269" r:id="Rd1cd242a8b134bc1"/>
-    <p:sldId id="270" r:id="Rff2a4823919b4ad3"/>
-    <p:sldId id="271" r:id="R7de376a165704b0b"/>
-    <p:sldId id="272" r:id="R3576b2142cff41d1"/>
-    <p:sldId id="273" r:id="R9a6d7a2e3c3f43ac"/>
-    <p:sldId id="274" r:id="R3cb0834b9319451b"/>
-    <p:sldId id="275" r:id="R5d1a8114a3cf4ce9"/>
-    <p:sldId id="276" r:id="R4b2e923736104ee7"/>
-    <p:sldId id="277" r:id="R8fb3b3cf83694e5d"/>
-    <p:sldId id="278" r:id="R283f2495686a40e3"/>
+    <p:sldId id="256" r:id="R8779a872e16f4854"/>
+    <p:sldId id="257" r:id="R76aee0f023a944af"/>
+    <p:sldId id="258" r:id="R27d69c8788564403"/>
+    <p:sldId id="259" r:id="R91879588f40e4cf4"/>
+    <p:sldId id="260" r:id="R62c11c2d12be406f"/>
+    <p:sldId id="261" r:id="Rcded1d101ebd462e"/>
+    <p:sldId id="262" r:id="R8ab48d57d8d14e84"/>
+    <p:sldId id="263" r:id="Rbd58dda284314cbf"/>
+    <p:sldId id="264" r:id="R08c2f145159f4a30"/>
+    <p:sldId id="265" r:id="Rb69556a0d2464a8a"/>
+    <p:sldId id="266" r:id="R19562009f3db42dc"/>
+    <p:sldId id="267" r:id="R42bb845092d94c1a"/>
+    <p:sldId id="268" r:id="R8008f176c0524d51"/>
+    <p:sldId id="269" r:id="Rfa44f95d03c74aed"/>
+    <p:sldId id="270" r:id="R7bec6688d73747ba"/>
+    <p:sldId id="271" r:id="Raca478a3cdf34661"/>
+    <p:sldId id="272" r:id="R02f19b66cdd34248"/>
+    <p:sldId id="273" r:id="R1d8aa7c56edd48d8"/>
+    <p:sldId id="274" r:id="R78e39a9c623c439d"/>
+    <p:sldId id="275" r:id="R11307f1f4c6c4cdb"/>
+    <p:sldId id="276" r:id="R38fa4971e27a42eb"/>
+    <p:sldId id="277" r:id="Rd20c1bc1eda84d83"/>
+    <p:sldId id="278" r:id="R583125b4e0c548da"/>
   </p:sldIdLst>
   <p:sldSz cx="12192000" cy="6858000"/>
   <p:notesSz cx="6858000" cy="9144000"/>
@@ -442,7 +442,7 @@
           <p:nvPr/>
         </p:nvPicPr>
         <p:blipFill>
-          <a:blip xmlns:r="http://schemas.openxmlformats.org/officeDocument/2006/relationships" r:embed="Rec3c569b1fa34d20"/>
+          <a:blip xmlns:r="http://schemas.openxmlformats.org/officeDocument/2006/relationships" r:embed="R276ae0edbf4945e3"/>
           <a:stretch>
             <a:fillRect/>
           </a:stretch>
@@ -507,15 +507,15 @@
           <p:nvPr/>
         </p:nvPicPr>
         <p:blipFill>
-          <a:blip xmlns:r="http://schemas.openxmlformats.org/officeDocument/2006/relationships" r:embed="R64676035f54842f6"/>
+          <a:blip xmlns:r="http://schemas.openxmlformats.org/officeDocument/2006/relationships" r:embed="Reac1df3e09da4ecf"/>
           <a:stretch>
             <a:fillRect/>
           </a:stretch>
         </p:blipFill>
         <p:spPr>
           <a:xfrm>
-            <a:off x="1233457" y="1097280"/>
-            <a:ext cx="9694606" cy="5303520"/>
+            <a:off x="1310398" y="1097280"/>
+            <a:ext cx="9540723" cy="5303520"/>
           </a:xfrm>
           <a:prstGeom prst="rect">
             <a:avLst/>
@@ -572,7 +572,7 @@
           <p:nvPr/>
         </p:nvPicPr>
         <p:blipFill>
-          <a:blip xmlns:r="http://schemas.openxmlformats.org/officeDocument/2006/relationships" r:embed="Raa9bf3b456a1495b"/>
+          <a:blip xmlns:r="http://schemas.openxmlformats.org/officeDocument/2006/relationships" r:embed="R0d291aef8f834d23"/>
           <a:stretch>
             <a:fillRect/>
           </a:stretch>
@@ -637,7 +637,7 @@
           <p:nvPr/>
         </p:nvPicPr>
         <p:blipFill>
-          <a:blip xmlns:r="http://schemas.openxmlformats.org/officeDocument/2006/relationships" r:embed="R85cd31c515a74223"/>
+          <a:blip xmlns:r="http://schemas.openxmlformats.org/officeDocument/2006/relationships" r:embed="R2acc56d92229430f"/>
           <a:stretch>
             <a:fillRect/>
           </a:stretch>
@@ -702,7 +702,7 @@
           <p:nvPr/>
         </p:nvPicPr>
         <p:blipFill>
-          <a:blip xmlns:r="http://schemas.openxmlformats.org/officeDocument/2006/relationships" r:embed="Re2eb421df50b4dc0"/>
+          <a:blip xmlns:r="http://schemas.openxmlformats.org/officeDocument/2006/relationships" r:embed="R8aeb1350f6674475"/>
           <a:stretch>
             <a:fillRect/>
           </a:stretch>
@@ -767,7 +767,7 @@
           <p:nvPr/>
         </p:nvPicPr>
         <p:blipFill>
-          <a:blip xmlns:r="http://schemas.openxmlformats.org/officeDocument/2006/relationships" r:embed="R80fa5a4bbe1e4f2f"/>
+          <a:blip xmlns:r="http://schemas.openxmlformats.org/officeDocument/2006/relationships" r:embed="Rfe9c8c5808ba4eb3"/>
           <a:stretch>
             <a:fillRect/>
           </a:stretch>
@@ -832,7 +832,7 @@
           <p:nvPr/>
         </p:nvPicPr>
         <p:blipFill>
-          <a:blip xmlns:r="http://schemas.openxmlformats.org/officeDocument/2006/relationships" r:embed="R3680db75df8245de"/>
+          <a:blip xmlns:r="http://schemas.openxmlformats.org/officeDocument/2006/relationships" r:embed="R55b6c31a19f6401e"/>
           <a:stretch>
             <a:fillRect/>
           </a:stretch>
@@ -897,7 +897,7 @@
           <p:nvPr/>
         </p:nvPicPr>
         <p:blipFill>
-          <a:blip xmlns:r="http://schemas.openxmlformats.org/officeDocument/2006/relationships" r:embed="Rc54419ff60c54333"/>
+          <a:blip xmlns:r="http://schemas.openxmlformats.org/officeDocument/2006/relationships" r:embed="Re7836ef4b7d84583"/>
           <a:stretch>
             <a:fillRect/>
           </a:stretch>
@@ -962,7 +962,7 @@
           <p:nvPr/>
         </p:nvPicPr>
         <p:blipFill>
-          <a:blip xmlns:r="http://schemas.openxmlformats.org/officeDocument/2006/relationships" r:embed="Rccb5fbd885a34e4d"/>
+          <a:blip xmlns:r="http://schemas.openxmlformats.org/officeDocument/2006/relationships" r:embed="R3c215d452dac418b"/>
           <a:stretch>
             <a:fillRect/>
           </a:stretch>
@@ -1027,7 +1027,7 @@
           <p:nvPr/>
         </p:nvPicPr>
         <p:blipFill>
-          <a:blip xmlns:r="http://schemas.openxmlformats.org/officeDocument/2006/relationships" r:embed="R235b8554f3d947e3"/>
+          <a:blip xmlns:r="http://schemas.openxmlformats.org/officeDocument/2006/relationships" r:embed="R506a653091bc458a"/>
           <a:stretch>
             <a:fillRect/>
           </a:stretch>
@@ -2063,7 +2063,7 @@
           <p:nvPr/>
         </p:nvPicPr>
         <p:blipFill>
-          <a:blip xmlns:r="http://schemas.openxmlformats.org/officeDocument/2006/relationships" r:embed="Raa1e16c7d15f4d18"/>
+          <a:blip xmlns:r="http://schemas.openxmlformats.org/officeDocument/2006/relationships" r:embed="R02a5d5f8943c40e8"/>
           <a:stretch>
             <a:fillRect/>
           </a:stretch>
@@ -2128,7 +2128,7 @@
           <p:nvPr/>
         </p:nvPicPr>
         <p:blipFill>
-          <a:blip xmlns:r="http://schemas.openxmlformats.org/officeDocument/2006/relationships" r:embed="Rabbfbda348f24c0a"/>
+          <a:blip xmlns:r="http://schemas.openxmlformats.org/officeDocument/2006/relationships" r:embed="R544ec82e7ac443eb"/>
           <a:stretch>
             <a:fillRect/>
           </a:stretch>
@@ -2193,7 +2193,7 @@
           <p:nvPr/>
         </p:nvPicPr>
         <p:blipFill>
-          <a:blip xmlns:r="http://schemas.openxmlformats.org/officeDocument/2006/relationships" r:embed="R7e7d4d39df3d447d"/>
+          <a:blip xmlns:r="http://schemas.openxmlformats.org/officeDocument/2006/relationships" r:embed="R5c03ad2e0032493c"/>
           <a:stretch>
             <a:fillRect/>
           </a:stretch>
@@ -2258,7 +2258,7 @@
           <p:nvPr/>
         </p:nvPicPr>
         <p:blipFill>
-          <a:blip xmlns:r="http://schemas.openxmlformats.org/officeDocument/2006/relationships" r:embed="R7508fe2de6a34c40"/>
+          <a:blip xmlns:r="http://schemas.openxmlformats.org/officeDocument/2006/relationships" r:embed="R81e1c0cc49fd473b"/>
           <a:stretch>
             <a:fillRect/>
           </a:stretch>
@@ -2323,7 +2323,7 @@
           <p:nvPr/>
         </p:nvPicPr>
         <p:blipFill>
-          <a:blip xmlns:r="http://schemas.openxmlformats.org/officeDocument/2006/relationships" r:embed="Rfb5e1a1e17454bf2"/>
+          <a:blip xmlns:r="http://schemas.openxmlformats.org/officeDocument/2006/relationships" r:embed="R0a0b511bdae64a38"/>
           <a:stretch>
             <a:fillRect/>
           </a:stretch>
@@ -2827,7 +2827,7 @@
           <p:nvPr/>
         </p:nvPicPr>
         <p:blipFill>
-          <a:blip xmlns:r="http://schemas.openxmlformats.org/officeDocument/2006/relationships" r:embed="Rd039ca5b6bbf4bec"/>
+          <a:blip xmlns:r="http://schemas.openxmlformats.org/officeDocument/2006/relationships" r:embed="Rd6ffa71863bf4423"/>
           <a:stretch>
             <a:fillRect/>
           </a:stretch>
@@ -2892,7 +2892,7 @@
           <p:nvPr/>
         </p:nvPicPr>
         <p:blipFill>
-          <a:blip xmlns:r="http://schemas.openxmlformats.org/officeDocument/2006/relationships" r:embed="Rb1bcb7ade1ef4c53"/>
+          <a:blip xmlns:r="http://schemas.openxmlformats.org/officeDocument/2006/relationships" r:embed="Rfc715365263b4e51"/>
           <a:stretch>
             <a:fillRect/>
           </a:stretch>
@@ -2957,7 +2957,7 @@
           <p:nvPr/>
         </p:nvPicPr>
         <p:blipFill>
-          <a:blip xmlns:r="http://schemas.openxmlformats.org/officeDocument/2006/relationships" r:embed="R16cdee46042143d0"/>
+          <a:blip xmlns:r="http://schemas.openxmlformats.org/officeDocument/2006/relationships" r:embed="R56154bae5c654205"/>
           <a:stretch>
             <a:fillRect/>
           </a:stretch>
@@ -3022,7 +3022,7 @@
           <p:nvPr/>
         </p:nvPicPr>
         <p:blipFill>
-          <a:blip xmlns:r="http://schemas.openxmlformats.org/officeDocument/2006/relationships" r:embed="R1f1caf4941f142d2"/>
+          <a:blip xmlns:r="http://schemas.openxmlformats.org/officeDocument/2006/relationships" r:embed="Re70cbc3849f34be3"/>
           <a:stretch>
             <a:fillRect/>
           </a:stretch>
@@ -3080,14 +3080,14 @@
       </p:sp>
       <p:pic>
         <p:nvPicPr>
-          <p:cNvPr id="100067" name="Picture 1" descr="mermaid:gantt&#10;  title Project Plan&#10;  dateFormat YYYY-MM-DD&#10;  todayMarker off&#10;  section Design&#10;  Research :a1, 2024-01-01, 5d&#10;  Draft :after a1, 4d&#10;  section Build&#10;  Code :2024-01-12, 6d"/>
+          <p:cNvPr id="100067" name="Picture 1" descr="mermaid:gantt&#10;  title Project Plan&#10;  dateFormat YYYY-MM-DD&#10;  axisFormat %b %d&#10;  tickInterval 1week&#10;  weekday monday&#10;  todayMarker off&#10;  section Design&#10;  Research :a1, 2024-01-01, 5d&#10;  Draft :after a1, 4d&#10;  section Build&#10;  Code :2024-01-12, 6d"/>
           <p:cNvPicPr>
             <a:picLocks noChangeAspect="1"/>
           </p:cNvPicPr>
           <p:nvPr/>
         </p:nvPicPr>
         <p:blipFill>
-          <a:blip xmlns:r="http://schemas.openxmlformats.org/officeDocument/2006/relationships" r:embed="R9a4c83a50a7a4564"/>
+          <a:blip xmlns:r="http://schemas.openxmlformats.org/officeDocument/2006/relationships" r:embed="R167e14bcf0b9419a"/>
           <a:stretch>
             <a:fillRect/>
           </a:stretch>

</xml_diff>